<commit_message>
Change English co-founder name to Jason Jeong
Co-Authored-By: Claude Fable 5 <noreply@anthropic.com>
Claude-Session: https://claude.ai/code/session_01NdSgsQRKAREDfNU5SmPuMT
</commit_message>
<xml_diff>
--- a/Dynamic_Industry_Elevator_Deck_EN.pptx
+++ b/Dynamic_Industry_Elevator_Deck_EN.pptx
@@ -2360,7 +2360,7 @@
                 <a:ea typeface="Calibri" pitchFamily="34" charset="-122"/>
                 <a:cs typeface="Calibri" pitchFamily="34" charset="-120"/>
               </a:rPr>
-              <a:t>Myung-geun Jung, Co-founder   ·   Aug 2026   ·   For investment review only</a:t>
+              <a:t>Jason Jeong, Co-founder   ·   Aug 2026   ·   For investment review only</a:t>
             </a:r>
             <a:endParaRPr lang="en-US" sz="950" dirty="0"/>
           </a:p>
@@ -8269,7 +8269,7 @@
                 <a:ea typeface="Calibri" pitchFamily="34" charset="-122"/>
                 <a:cs typeface="Calibri" pitchFamily="34" charset="-120"/>
               </a:rPr>
-              <a:t>Myung-geun Jung, Co-founder · jmk4893@dynamicindustry.kr</a:t>
+              <a:t>Jason Jeong, Co-founder · jmk4893@dynamicindustry.kr</a:t>
             </a:r>
             <a:endParaRPr lang="en-US" sz="1050" dirty="0"/>
           </a:p>

</xml_diff>